<commit_message>
fix: supervisor name, add flowchart, feature importance, expand report to ~60 pages
</commit_message>
<xml_diff>
--- a/ids_Defence_Slides.pptx
+++ b/ids_Defence_Slides.pptx
@@ -3339,7 +3339,7 @@
                 </a:solidFill>
                 <a:latin typeface="Segoe UI"/>
               </a:rPr>
-              <a:t>Supervisor: 'Prof. A. J. Ikuomola'</a:t>
+              <a:t>Supervisor: 'Dr. (Engr.) Modupe Agagu'</a:t>
             </a:r>
           </a:p>
           <a:p>
@@ -7569,60 +7569,14 @@
       </p:sp>
       <p:sp>
         <p:nvSpPr>
-          <p:cNvPr id="5" name="Rectangle 4"/>
-          <p:cNvSpPr/>
-          <p:nvPr/>
-        </p:nvSpPr>
-        <p:spPr>
-          <a:xfrm>
-            <a:off x="685800" y="1783080"/>
-            <a:ext cx="5257800" cy="4434840"/>
-          </a:xfrm>
-          <a:prstGeom prst="rect">
-            <a:avLst/>
-          </a:prstGeom>
-          <a:solidFill>
-            <a:srgbClr val="F4F4F4"/>
-          </a:solidFill>
-          <a:ln w="12700">
-            <a:solidFill>
-              <a:srgbClr val="000000"/>
-            </a:solidFill>
-          </a:ln>
-          <a:effectLst/>
-        </p:spPr>
-        <p:style>
-          <a:lnRef idx="1">
-            <a:schemeClr val="accent1"/>
-          </a:lnRef>
-          <a:fillRef idx="3">
-            <a:schemeClr val="accent1"/>
-          </a:fillRef>
-          <a:effectRef idx="2">
-            <a:schemeClr val="accent1"/>
-          </a:effectRef>
-          <a:fontRef idx="minor">
-            <a:schemeClr val="lt1"/>
-          </a:fontRef>
-        </p:style>
-        <p:txBody>
-          <a:bodyPr rtlCol="0" anchor="ctr"/>
-          <a:lstStyle/>
-          <a:p>
-            <a:pPr algn="ctr"/>
-          </a:p>
-        </p:txBody>
-      </p:sp>
-      <p:sp>
-        <p:nvSpPr>
-          <p:cNvPr id="6" name="TextBox 5"/>
+          <p:cNvPr id="5" name="TextBox 4"/>
           <p:cNvSpPr txBox="1"/>
           <p:nvPr/>
         </p:nvSpPr>
         <p:spPr>
           <a:xfrm>
-            <a:off x="960120" y="1965960"/>
-            <a:ext cx="4709160" cy="365760"/>
+            <a:off x="685800" y="1737360"/>
+            <a:ext cx="10881360" cy="4754880"/>
           </a:xfrm>
           <a:prstGeom prst="rect">
             <a:avLst/>
@@ -7630,235 +7584,120 @@
           <a:noFill/>
         </p:spPr>
         <p:txBody>
-          <a:bodyPr wrap="square" anchor="t">
+          <a:bodyPr wrap="square">
             <a:spAutoFit/>
           </a:bodyPr>
           <a:lstStyle/>
           <a:p>
-            <a:pPr algn="l">
-              <a:spcAft>
-                <a:spcPts val="600"/>
-              </a:spcAft>
-            </a:pPr>
-            <a:r>
-              <a:rPr sz="1500" b="1">
+            <a:pPr>
+              <a:spcAft>
+                <a:spcPts val="1000"/>
+              </a:spcAft>
+            </a:pPr>
+            <a:r>
+              <a:rPr sz="1800">
                 <a:solidFill>
                   <a:srgbClr val="000000"/>
                 </a:solidFill>
                 <a:latin typeface="Segoe UI"/>
               </a:rPr>
-              <a:t>Figure 3: Confusion Matrix</a:t>
-            </a:r>
-          </a:p>
-        </p:txBody>
-      </p:sp>
-      <p:pic>
-        <p:nvPicPr>
-          <p:cNvPr id="7" name="Picture 6" descr="confusion_matrix.png"/>
-          <p:cNvPicPr>
-            <a:picLocks noChangeAspect="1"/>
-          </p:cNvPicPr>
-          <p:nvPr/>
-        </p:nvPicPr>
-        <p:blipFill>
-          <a:blip r:embed="rId2"/>
-          <a:stretch>
-            <a:fillRect/>
-          </a:stretch>
-        </p:blipFill>
-        <p:spPr>
-          <a:xfrm>
-            <a:off x="1005840" y="2441448"/>
-            <a:ext cx="4617720" cy="3463290"/>
-          </a:xfrm>
-          <a:prstGeom prst="rect">
-            <a:avLst/>
-          </a:prstGeom>
-        </p:spPr>
-      </p:pic>
-      <p:sp>
-        <p:nvSpPr>
-          <p:cNvPr id="8" name="TextBox 7"/>
-          <p:cNvSpPr txBox="1"/>
-          <p:nvPr/>
-        </p:nvSpPr>
-        <p:spPr>
-          <a:xfrm>
-            <a:off x="960120" y="5852160"/>
-            <a:ext cx="4709160" cy="320040"/>
-          </a:xfrm>
-          <a:prstGeom prst="rect">
-            <a:avLst/>
-          </a:prstGeom>
-          <a:noFill/>
-        </p:spPr>
-        <p:txBody>
-          <a:bodyPr wrap="square" anchor="t">
-            <a:spAutoFit/>
-          </a:bodyPr>
-          <a:lstStyle/>
-          <a:p>
-            <a:pPr algn="ctr">
-              <a:spcAft>
-                <a:spcPts val="600"/>
-              </a:spcAft>
-            </a:pPr>
-            <a:r>
-              <a:rPr sz="1150" b="0">
-                <a:solidFill>
-                  <a:srgbClr val="333333"/>
-                </a:solidFill>
-                <a:latin typeface="Segoe UI"/>
-              </a:rPr>
-              <a:t>Model achieves near-perfect classification on the test set.</a:t>
-            </a:r>
-          </a:p>
-        </p:txBody>
-      </p:sp>
-      <p:sp>
-        <p:nvSpPr>
-          <p:cNvPr id="9" name="Rectangle 8"/>
-          <p:cNvSpPr/>
-          <p:nvPr/>
-        </p:nvSpPr>
-        <p:spPr>
-          <a:xfrm>
-            <a:off x="6217920" y="1783080"/>
-            <a:ext cx="5257800" cy="4434840"/>
-          </a:xfrm>
-          <a:prstGeom prst="rect">
-            <a:avLst/>
-          </a:prstGeom>
-          <a:solidFill>
-            <a:srgbClr val="F4F4F4"/>
-          </a:solidFill>
-          <a:ln w="12700">
-            <a:solidFill>
-              <a:srgbClr val="000000"/>
-            </a:solidFill>
-          </a:ln>
-          <a:effectLst/>
-        </p:spPr>
-        <p:style>
-          <a:lnRef idx="1">
-            <a:schemeClr val="accent1"/>
-          </a:lnRef>
-          <a:fillRef idx="3">
-            <a:schemeClr val="accent1"/>
-          </a:fillRef>
-          <a:effectRef idx="2">
-            <a:schemeClr val="accent1"/>
-          </a:effectRef>
-          <a:fontRef idx="minor">
-            <a:schemeClr val="lt1"/>
-          </a:fontRef>
-        </p:style>
-        <p:txBody>
-          <a:bodyPr rtlCol="0" anchor="ctr"/>
-          <a:lstStyle/>
-          <a:p>
-            <a:pPr algn="ctr"/>
-          </a:p>
-        </p:txBody>
-      </p:sp>
-      <p:sp>
-        <p:nvSpPr>
-          <p:cNvPr id="10" name="TextBox 9"/>
-          <p:cNvSpPr txBox="1"/>
-          <p:nvPr/>
-        </p:nvSpPr>
-        <p:spPr>
-          <a:xfrm>
-            <a:off x="6492240" y="1965960"/>
-            <a:ext cx="4709160" cy="365760"/>
-          </a:xfrm>
-          <a:prstGeom prst="rect">
-            <a:avLst/>
-          </a:prstGeom>
-          <a:noFill/>
-        </p:spPr>
-        <p:txBody>
-          <a:bodyPr wrap="square" anchor="t">
-            <a:spAutoFit/>
-          </a:bodyPr>
-          <a:lstStyle/>
-          <a:p>
-            <a:pPr algn="l">
-              <a:spcAft>
-                <a:spcPts val="600"/>
-              </a:spcAft>
-            </a:pPr>
-            <a:r>
-              <a:rPr sz="1500" b="1">
+              <a:t>▸  Accuracy: 99.9% — 999 out of 1000 flows correctly classified.</a:t>
+            </a:r>
+          </a:p>
+          <a:p>
+            <a:pPr>
+              <a:spcAft>
+                <a:spcPts val="1000"/>
+              </a:spcAft>
+            </a:pPr>
+            <a:r>
+              <a:rPr sz="1800">
                 <a:solidFill>
                   <a:srgbClr val="000000"/>
                 </a:solidFill>
                 <a:latin typeface="Segoe UI"/>
               </a:rPr>
-              <a:t>Figure 4: ROC Curve</a:t>
-            </a:r>
-          </a:p>
-        </p:txBody>
-      </p:sp>
-      <p:pic>
-        <p:nvPicPr>
-          <p:cNvPr id="11" name="Picture 10" descr="roc_curve.png"/>
-          <p:cNvPicPr>
-            <a:picLocks noChangeAspect="1"/>
-          </p:cNvPicPr>
-          <p:nvPr/>
-        </p:nvPicPr>
-        <p:blipFill>
-          <a:blip r:embed="rId3"/>
-          <a:stretch>
-            <a:fillRect/>
-          </a:stretch>
-        </p:blipFill>
-        <p:spPr>
-          <a:xfrm>
-            <a:off x="6537960" y="2441448"/>
-            <a:ext cx="4617720" cy="3463290"/>
-          </a:xfrm>
-          <a:prstGeom prst="rect">
-            <a:avLst/>
-          </a:prstGeom>
-        </p:spPr>
-      </p:pic>
-      <p:sp>
-        <p:nvSpPr>
-          <p:cNvPr id="12" name="TextBox 11"/>
-          <p:cNvSpPr txBox="1"/>
-          <p:nvPr/>
-        </p:nvSpPr>
-        <p:spPr>
-          <a:xfrm>
-            <a:off x="6492240" y="5852160"/>
-            <a:ext cx="4709160" cy="320040"/>
-          </a:xfrm>
-          <a:prstGeom prst="rect">
-            <a:avLst/>
-          </a:prstGeom>
-          <a:noFill/>
-        </p:spPr>
-        <p:txBody>
-          <a:bodyPr wrap="square" anchor="t">
-            <a:spAutoFit/>
-          </a:bodyPr>
-          <a:lstStyle/>
-          <a:p>
-            <a:pPr algn="ctr">
-              <a:spcAft>
-                <a:spcPts val="600"/>
-              </a:spcAft>
-            </a:pPr>
-            <a:r>
-              <a:rPr sz="1150" b="0">
-                <a:solidFill>
-                  <a:srgbClr val="333333"/>
-                </a:solidFill>
-                <a:latin typeface="Segoe UI"/>
-              </a:rPr>
-              <a:t>ROC-AUC of 0.9999 demonstrates excellent discrimination.</a:t>
+              <a:t>▸  ROC-AUC: 0.9999 — near-perfect discrimination between benign and malicious.</a:t>
+            </a:r>
+          </a:p>
+          <a:p>
+            <a:pPr>
+              <a:spcAft>
+                <a:spcPts val="1000"/>
+              </a:spcAft>
+            </a:pPr>
+            <a:r>
+              <a:rPr sz="1800">
+                <a:solidFill>
+                  <a:srgbClr val="000000"/>
+                </a:solidFill>
+                <a:latin typeface="Segoe UI"/>
+              </a:rPr>
+              <a:t>▸  Precision: 0.999 | Recall: 0.999 | F1-Score: 0.999.</a:t>
+            </a:r>
+          </a:p>
+          <a:p>
+            <a:pPr>
+              <a:spcAft>
+                <a:spcPts val="1000"/>
+              </a:spcAft>
+            </a:pPr>
+            <a:r>
+              <a:rPr sz="1800">
+                <a:solidFill>
+                  <a:srgbClr val="000000"/>
+                </a:solidFill>
+                <a:latin typeface="Segoe UI"/>
+              </a:rPr>
+              <a:t>▸  Confusion matrix shows near-diagonal dominance (minimal FP/FN).</a:t>
+            </a:r>
+          </a:p>
+          <a:p>
+            <a:pPr>
+              <a:spcAft>
+                <a:spcPts val="1000"/>
+              </a:spcAft>
+            </a:pPr>
+            <a:r>
+              <a:rPr sz="1800">
+                <a:solidFill>
+                  <a:srgbClr val="000000"/>
+                </a:solidFill>
+                <a:latin typeface="Segoe UI"/>
+              </a:rPr>
+              <a:t>▸  Feature importance: flow duration, backward packet length, inter-arrival times.</a:t>
+            </a:r>
+          </a:p>
+          <a:p>
+            <a:pPr>
+              <a:spcAft>
+                <a:spcPts val="1000"/>
+              </a:spcAft>
+            </a:pPr>
+            <a:r>
+              <a:rPr sz="1800">
+                <a:solidFill>
+                  <a:srgbClr val="000000"/>
+                </a:solidFill>
+                <a:latin typeface="Segoe UI"/>
+              </a:rPr>
+              <a:t>▸  All three modes (CSV, PCAP, Live) passed unit, integration, and UAT testing.</a:t>
+            </a:r>
+          </a:p>
+          <a:p>
+            <a:pPr>
+              <a:spcAft>
+                <a:spcPts val="1000"/>
+              </a:spcAft>
+            </a:pPr>
+            <a:r>
+              <a:rPr sz="1800">
+                <a:solidFill>
+                  <a:srgbClr val="000000"/>
+                </a:solidFill>
+                <a:latin typeface="Segoe UI"/>
+              </a:rPr>
+              <a:t>▸  AI assistant provides accurate plain-language explanations of predictions.</a:t>
             </a:r>
           </a:p>
         </p:txBody>

</xml_diff>